<commit_message>
new notes about dbt
</commit_message>
<xml_diff>
--- a/dbt/dbt benefits.pptx
+++ b/dbt/dbt benefits.pptx
@@ -7,9 +7,14 @@
   <p:sldIdLst>
     <p:sldId id="256" r:id="rId2"/>
     <p:sldId id="257" r:id="rId3"/>
-    <p:sldId id="258" r:id="rId4"/>
-    <p:sldId id="259" r:id="rId5"/>
-    <p:sldId id="260" r:id="rId6"/>
+    <p:sldId id="263" r:id="rId4"/>
+    <p:sldId id="258" r:id="rId5"/>
+    <p:sldId id="259" r:id="rId6"/>
+    <p:sldId id="262" r:id="rId7"/>
+    <p:sldId id="260" r:id="rId8"/>
+    <p:sldId id="261" r:id="rId9"/>
+    <p:sldId id="265" r:id="rId10"/>
+    <p:sldId id="264" r:id="rId11"/>
   </p:sldIdLst>
   <p:sldSz cx="12192000" cy="6858000"/>
   <p:notesSz cx="6858000" cy="9144000"/>
@@ -108,6 +113,11 @@
       </a:defRPr>
     </a:lvl9pPr>
   </p:defaultTextStyle>
+  <p:extLst>
+    <p:ext uri="{EFAFB233-063F-42B5-8137-9DF3F51BA10A}">
+      <p15:sldGuideLst xmlns:p15="http://schemas.microsoft.com/office/powerpoint/2012/main"/>
+    </p:ext>
+  </p:extLst>
 </p:presentation>
 </file>
 
@@ -258,7 +268,7 @@
           <a:p>
             <a:fld id="{B64590F3-3DC3-4711-864C-EB4C1863B33D}" type="datetimeFigureOut">
               <a:rPr lang="en-US" smtClean="0"/>
-              <a:t>5/28/2025</a:t>
+              <a:t>6/7/2025</a:t>
             </a:fld>
             <a:endParaRPr lang="en-US"/>
           </a:p>
@@ -456,7 +466,7 @@
           <a:p>
             <a:fld id="{B64590F3-3DC3-4711-864C-EB4C1863B33D}" type="datetimeFigureOut">
               <a:rPr lang="en-US" smtClean="0"/>
-              <a:t>5/28/2025</a:t>
+              <a:t>6/7/2025</a:t>
             </a:fld>
             <a:endParaRPr lang="en-US"/>
           </a:p>
@@ -664,7 +674,7 @@
           <a:p>
             <a:fld id="{B64590F3-3DC3-4711-864C-EB4C1863B33D}" type="datetimeFigureOut">
               <a:rPr lang="en-US" smtClean="0"/>
-              <a:t>5/28/2025</a:t>
+              <a:t>6/7/2025</a:t>
             </a:fld>
             <a:endParaRPr lang="en-US"/>
           </a:p>
@@ -862,7 +872,7 @@
           <a:p>
             <a:fld id="{B64590F3-3DC3-4711-864C-EB4C1863B33D}" type="datetimeFigureOut">
               <a:rPr lang="en-US" smtClean="0"/>
-              <a:t>5/28/2025</a:t>
+              <a:t>6/7/2025</a:t>
             </a:fld>
             <a:endParaRPr lang="en-US"/>
           </a:p>
@@ -1137,7 +1147,7 @@
           <a:p>
             <a:fld id="{B64590F3-3DC3-4711-864C-EB4C1863B33D}" type="datetimeFigureOut">
               <a:rPr lang="en-US" smtClean="0"/>
-              <a:t>5/28/2025</a:t>
+              <a:t>6/7/2025</a:t>
             </a:fld>
             <a:endParaRPr lang="en-US"/>
           </a:p>
@@ -1402,7 +1412,7 @@
           <a:p>
             <a:fld id="{B64590F3-3DC3-4711-864C-EB4C1863B33D}" type="datetimeFigureOut">
               <a:rPr lang="en-US" smtClean="0"/>
-              <a:t>5/28/2025</a:t>
+              <a:t>6/7/2025</a:t>
             </a:fld>
             <a:endParaRPr lang="en-US"/>
           </a:p>
@@ -1814,7 +1824,7 @@
           <a:p>
             <a:fld id="{B64590F3-3DC3-4711-864C-EB4C1863B33D}" type="datetimeFigureOut">
               <a:rPr lang="en-US" smtClean="0"/>
-              <a:t>5/28/2025</a:t>
+              <a:t>6/7/2025</a:t>
             </a:fld>
             <a:endParaRPr lang="en-US"/>
           </a:p>
@@ -1955,7 +1965,7 @@
           <a:p>
             <a:fld id="{B64590F3-3DC3-4711-864C-EB4C1863B33D}" type="datetimeFigureOut">
               <a:rPr lang="en-US" smtClean="0"/>
-              <a:t>5/28/2025</a:t>
+              <a:t>6/7/2025</a:t>
             </a:fld>
             <a:endParaRPr lang="en-US"/>
           </a:p>
@@ -2068,7 +2078,7 @@
           <a:p>
             <a:fld id="{B64590F3-3DC3-4711-864C-EB4C1863B33D}" type="datetimeFigureOut">
               <a:rPr lang="en-US" smtClean="0"/>
-              <a:t>5/28/2025</a:t>
+              <a:t>6/7/2025</a:t>
             </a:fld>
             <a:endParaRPr lang="en-US"/>
           </a:p>
@@ -2379,7 +2389,7 @@
           <a:p>
             <a:fld id="{B64590F3-3DC3-4711-864C-EB4C1863B33D}" type="datetimeFigureOut">
               <a:rPr lang="en-US" smtClean="0"/>
-              <a:t>5/28/2025</a:t>
+              <a:t>6/7/2025</a:t>
             </a:fld>
             <a:endParaRPr lang="en-US"/>
           </a:p>
@@ -2667,7 +2677,7 @@
           <a:p>
             <a:fld id="{B64590F3-3DC3-4711-864C-EB4C1863B33D}" type="datetimeFigureOut">
               <a:rPr lang="en-US" smtClean="0"/>
-              <a:t>5/28/2025</a:t>
+              <a:t>6/7/2025</a:t>
             </a:fld>
             <a:endParaRPr lang="en-US"/>
           </a:p>
@@ -2908,7 +2918,7 @@
           <a:p>
             <a:fld id="{B64590F3-3DC3-4711-864C-EB4C1863B33D}" type="datetimeFigureOut">
               <a:rPr lang="en-US" smtClean="0"/>
-              <a:t>5/28/2025</a:t>
+              <a:t>6/7/2025</a:t>
             </a:fld>
             <a:endParaRPr lang="en-US"/>
           </a:p>
@@ -4197,6 +4207,252 @@
 </p:sld>
 </file>
 
+<file path=ppt/slides/slide10.xml><?xml version="1.0" encoding="utf-8"?>
+<p:sld xmlns:a="http://schemas.openxmlformats.org/drawingml/2006/main" xmlns:r="http://schemas.openxmlformats.org/officeDocument/2006/relationships" xmlns:p="http://schemas.openxmlformats.org/presentationml/2006/main">
+  <p:cSld>
+    <p:spTree>
+      <p:nvGrpSpPr>
+        <p:cNvPr id="1" name="">
+          <a:extLst>
+            <a:ext uri="{FF2B5EF4-FFF2-40B4-BE49-F238E27FC236}">
+              <a16:creationId xmlns:a16="http://schemas.microsoft.com/office/drawing/2014/main" id="{7C72BDAF-62A2-E4F6-2426-9A85D0D7073F}"/>
+            </a:ext>
+          </a:extLst>
+        </p:cNvPr>
+        <p:cNvGrpSpPr/>
+        <p:nvPr/>
+      </p:nvGrpSpPr>
+      <p:grpSpPr>
+        <a:xfrm>
+          <a:off x="0" y="0"/>
+          <a:ext cx="0" cy="0"/>
+          <a:chOff x="0" y="0"/>
+          <a:chExt cx="0" cy="0"/>
+        </a:xfrm>
+      </p:grpSpPr>
+      <p:sp>
+        <p:nvSpPr>
+          <p:cNvPr id="4" name="TextBox 3">
+            <a:extLst>
+              <a:ext uri="{FF2B5EF4-FFF2-40B4-BE49-F238E27FC236}">
+                <a16:creationId xmlns:a16="http://schemas.microsoft.com/office/drawing/2014/main" id="{1B53A043-9684-553A-C85C-571372FBE6E0}"/>
+              </a:ext>
+            </a:extLst>
+          </p:cNvPr>
+          <p:cNvSpPr txBox="1"/>
+          <p:nvPr/>
+        </p:nvSpPr>
+        <p:spPr>
+          <a:xfrm>
+            <a:off x="0" y="0"/>
+            <a:ext cx="12192000" cy="523220"/>
+          </a:xfrm>
+          <a:prstGeom prst="rect">
+            <a:avLst/>
+          </a:prstGeom>
+          <a:noFill/>
+        </p:spPr>
+        <p:txBody>
+          <a:bodyPr wrap="square" rtlCol="0">
+            <a:spAutoFit/>
+          </a:bodyPr>
+          <a:lstStyle/>
+          <a:p>
+            <a:pPr algn="ctr"/>
+            <a:r>
+              <a:rPr lang="en-US" sz="2800" b="1" dirty="0"/>
+              <a:t>Macros</a:t>
+            </a:r>
+            <a:endParaRPr lang="en-US" sz="2500" b="1" dirty="0"/>
+          </a:p>
+        </p:txBody>
+      </p:sp>
+      <p:sp>
+        <p:nvSpPr>
+          <p:cNvPr id="5" name="TextBox 4">
+            <a:extLst>
+              <a:ext uri="{FF2B5EF4-FFF2-40B4-BE49-F238E27FC236}">
+                <a16:creationId xmlns:a16="http://schemas.microsoft.com/office/drawing/2014/main" id="{F7052611-ECF3-D7A8-F2F2-8BBE1D1E2A0E}"/>
+              </a:ext>
+            </a:extLst>
+          </p:cNvPr>
+          <p:cNvSpPr txBox="1"/>
+          <p:nvPr/>
+        </p:nvSpPr>
+        <p:spPr>
+          <a:xfrm>
+            <a:off x="0" y="543626"/>
+            <a:ext cx="12192000" cy="923330"/>
+          </a:xfrm>
+          <a:prstGeom prst="rect">
+            <a:avLst/>
+          </a:prstGeom>
+          <a:noFill/>
+        </p:spPr>
+        <p:txBody>
+          <a:bodyPr wrap="square" rtlCol="0">
+            <a:spAutoFit/>
+          </a:bodyPr>
+          <a:lstStyle/>
+          <a:p>
+            <a:r>
+              <a:rPr lang="en-US" dirty="0"/>
+              <a:t>Macros are functions which we can use in our SQL queries. For example below we have a macro which is returning a data which is a beginning of a financial year specified number of years ago. It assumes that financial year begins at October. Below is also a query which is using this macro. In </a:t>
+            </a:r>
+            <a:r>
+              <a:rPr lang="en-US" dirty="0" err="1"/>
+              <a:t>dbt</a:t>
+            </a:r>
+            <a:r>
+              <a:rPr lang="en-US" dirty="0"/>
+              <a:t> we can use Jinja except for SQL which gives us more flexibility.</a:t>
+            </a:r>
+          </a:p>
+        </p:txBody>
+      </p:sp>
+      <p:pic>
+        <p:nvPicPr>
+          <p:cNvPr id="3" name="Picture 2">
+            <a:extLst>
+              <a:ext uri="{FF2B5EF4-FFF2-40B4-BE49-F238E27FC236}">
+                <a16:creationId xmlns:a16="http://schemas.microsoft.com/office/drawing/2014/main" id="{C0EF7377-828C-1A75-ACA4-293192221F64}"/>
+              </a:ext>
+            </a:extLst>
+          </p:cNvPr>
+          <p:cNvPicPr>
+            <a:picLocks noChangeAspect="1"/>
+          </p:cNvPicPr>
+          <p:nvPr/>
+        </p:nvPicPr>
+        <p:blipFill>
+          <a:blip r:embed="rId2"/>
+          <a:stretch>
+            <a:fillRect/>
+          </a:stretch>
+        </p:blipFill>
+        <p:spPr>
+          <a:xfrm>
+            <a:off x="193404" y="2696156"/>
+            <a:ext cx="7258455" cy="4161844"/>
+          </a:xfrm>
+          <a:prstGeom prst="rect">
+            <a:avLst/>
+          </a:prstGeom>
+        </p:spPr>
+      </p:pic>
+      <p:pic>
+        <p:nvPicPr>
+          <p:cNvPr id="10" name="Picture 9">
+            <a:extLst>
+              <a:ext uri="{FF2B5EF4-FFF2-40B4-BE49-F238E27FC236}">
+                <a16:creationId xmlns:a16="http://schemas.microsoft.com/office/drawing/2014/main" id="{5C6D75E2-71AF-03BC-332E-870D050E0C71}"/>
+              </a:ext>
+            </a:extLst>
+          </p:cNvPr>
+          <p:cNvPicPr>
+            <a:picLocks noChangeAspect="1"/>
+          </p:cNvPicPr>
+          <p:nvPr/>
+        </p:nvPicPr>
+        <p:blipFill>
+          <a:blip r:embed="rId3"/>
+          <a:stretch>
+            <a:fillRect/>
+          </a:stretch>
+        </p:blipFill>
+        <p:spPr>
+          <a:xfrm>
+            <a:off x="8684863" y="4132205"/>
+            <a:ext cx="2753109" cy="1943371"/>
+          </a:xfrm>
+          <a:prstGeom prst="rect">
+            <a:avLst/>
+          </a:prstGeom>
+        </p:spPr>
+      </p:pic>
+      <p:sp>
+        <p:nvSpPr>
+          <p:cNvPr id="11" name="TextBox 10">
+            <a:extLst>
+              <a:ext uri="{FF2B5EF4-FFF2-40B4-BE49-F238E27FC236}">
+                <a16:creationId xmlns:a16="http://schemas.microsoft.com/office/drawing/2014/main" id="{EED06974-3AA0-03D5-69C3-F3E6BE8241E6}"/>
+              </a:ext>
+            </a:extLst>
+          </p:cNvPr>
+          <p:cNvSpPr txBox="1"/>
+          <p:nvPr/>
+        </p:nvSpPr>
+        <p:spPr>
+          <a:xfrm>
+            <a:off x="2697932" y="2245259"/>
+            <a:ext cx="1798954" cy="369332"/>
+          </a:xfrm>
+          <a:prstGeom prst="rect">
+            <a:avLst/>
+          </a:prstGeom>
+          <a:noFill/>
+        </p:spPr>
+        <p:txBody>
+          <a:bodyPr wrap="none" rtlCol="0">
+            <a:spAutoFit/>
+          </a:bodyPr>
+          <a:lstStyle/>
+          <a:p>
+            <a:r>
+              <a:rPr lang="en-US" dirty="0"/>
+              <a:t>Macro definition</a:t>
+            </a:r>
+          </a:p>
+        </p:txBody>
+      </p:sp>
+      <p:sp>
+        <p:nvSpPr>
+          <p:cNvPr id="12" name="TextBox 11">
+            <a:extLst>
+              <a:ext uri="{FF2B5EF4-FFF2-40B4-BE49-F238E27FC236}">
+                <a16:creationId xmlns:a16="http://schemas.microsoft.com/office/drawing/2014/main" id="{933C71A4-2CF0-E93F-07DF-3AAEBD435536}"/>
+              </a:ext>
+            </a:extLst>
+          </p:cNvPr>
+          <p:cNvSpPr txBox="1"/>
+          <p:nvPr/>
+        </p:nvSpPr>
+        <p:spPr>
+          <a:xfrm>
+            <a:off x="9161940" y="3601770"/>
+            <a:ext cx="1455848" cy="369332"/>
+          </a:xfrm>
+          <a:prstGeom prst="rect">
+            <a:avLst/>
+          </a:prstGeom>
+          <a:noFill/>
+        </p:spPr>
+        <p:txBody>
+          <a:bodyPr wrap="none" rtlCol="0">
+            <a:spAutoFit/>
+          </a:bodyPr>
+          <a:lstStyle/>
+          <a:p>
+            <a:r>
+              <a:rPr lang="en-US" dirty="0"/>
+              <a:t>Macro usage</a:t>
+            </a:r>
+          </a:p>
+        </p:txBody>
+      </p:sp>
+    </p:spTree>
+    <p:extLst>
+      <p:ext uri="{BB962C8B-B14F-4D97-AF65-F5344CB8AC3E}">
+        <p14:creationId xmlns:p14="http://schemas.microsoft.com/office/powerpoint/2010/main" val="4192894699"/>
+      </p:ext>
+    </p:extLst>
+  </p:cSld>
+  <p:clrMapOvr>
+    <a:masterClrMapping/>
+  </p:clrMapOvr>
+</p:sld>
+</file>
+
 <file path=ppt/slides/slide2.xml><?xml version="1.0" encoding="utf-8"?>
 <p:sld xmlns:a="http://schemas.openxmlformats.org/drawingml/2006/main" xmlns:r="http://schemas.openxmlformats.org/officeDocument/2006/relationships" xmlns:p="http://schemas.openxmlformats.org/presentationml/2006/main">
   <p:cSld>
@@ -4380,6 +4636,252 @@
         <p:cNvPr id="1" name="">
           <a:extLst>
             <a:ext uri="{FF2B5EF4-FFF2-40B4-BE49-F238E27FC236}">
+              <a16:creationId xmlns:a16="http://schemas.microsoft.com/office/drawing/2014/main" id="{0D01C410-09F3-7CFF-4718-7F0F47C02CA8}"/>
+            </a:ext>
+          </a:extLst>
+        </p:cNvPr>
+        <p:cNvGrpSpPr/>
+        <p:nvPr/>
+      </p:nvGrpSpPr>
+      <p:grpSpPr>
+        <a:xfrm>
+          <a:off x="0" y="0"/>
+          <a:ext cx="0" cy="0"/>
+          <a:chOff x="0" y="0"/>
+          <a:chExt cx="0" cy="0"/>
+        </a:xfrm>
+      </p:grpSpPr>
+      <p:sp>
+        <p:nvSpPr>
+          <p:cNvPr id="4" name="TextBox 3">
+            <a:extLst>
+              <a:ext uri="{FF2B5EF4-FFF2-40B4-BE49-F238E27FC236}">
+                <a16:creationId xmlns:a16="http://schemas.microsoft.com/office/drawing/2014/main" id="{B157A39E-0F74-E090-4ABD-5D46AEF759B7}"/>
+              </a:ext>
+            </a:extLst>
+          </p:cNvPr>
+          <p:cNvSpPr txBox="1"/>
+          <p:nvPr/>
+        </p:nvSpPr>
+        <p:spPr>
+          <a:xfrm>
+            <a:off x="0" y="0"/>
+            <a:ext cx="12192000" cy="523220"/>
+          </a:xfrm>
+          <a:prstGeom prst="rect">
+            <a:avLst/>
+          </a:prstGeom>
+          <a:noFill/>
+        </p:spPr>
+        <p:txBody>
+          <a:bodyPr wrap="square" rtlCol="0">
+            <a:spAutoFit/>
+          </a:bodyPr>
+          <a:lstStyle/>
+          <a:p>
+            <a:pPr algn="ctr"/>
+            <a:r>
+              <a:rPr lang="en-US" sz="2800" b="1" dirty="0"/>
+              <a:t>Slowly changing dimensions type 2</a:t>
+            </a:r>
+            <a:endParaRPr lang="en-US" sz="2500" b="1" dirty="0"/>
+          </a:p>
+        </p:txBody>
+      </p:sp>
+      <p:sp>
+        <p:nvSpPr>
+          <p:cNvPr id="5" name="TextBox 4">
+            <a:extLst>
+              <a:ext uri="{FF2B5EF4-FFF2-40B4-BE49-F238E27FC236}">
+                <a16:creationId xmlns:a16="http://schemas.microsoft.com/office/drawing/2014/main" id="{E7F3A9C3-6671-3E7C-87BF-EEB6E2A61F37}"/>
+              </a:ext>
+            </a:extLst>
+          </p:cNvPr>
+          <p:cNvSpPr txBox="1"/>
+          <p:nvPr/>
+        </p:nvSpPr>
+        <p:spPr>
+          <a:xfrm>
+            <a:off x="0" y="543626"/>
+            <a:ext cx="12192000" cy="3139321"/>
+          </a:xfrm>
+          <a:prstGeom prst="rect">
+            <a:avLst/>
+          </a:prstGeom>
+          <a:noFill/>
+        </p:spPr>
+        <p:txBody>
+          <a:bodyPr wrap="square" rtlCol="0">
+            <a:spAutoFit/>
+          </a:bodyPr>
+          <a:lstStyle/>
+          <a:p>
+            <a:r>
+              <a:rPr lang="en-US" dirty="0"/>
+              <a:t>We can use snapshots in order to create slowly changing dimensions type 2. We are defining snapshots in a YAML file. </a:t>
+            </a:r>
+          </a:p>
+          <a:p>
+            <a:endParaRPr lang="en-US" dirty="0"/>
+          </a:p>
+          <a:p>
+            <a:r>
+              <a:rPr lang="en-US" dirty="0"/>
+              <a:t>For example, in the below snapshot we are creating snapshot in such a way that we will create a new record </a:t>
+            </a:r>
+            <a:r>
+              <a:rPr lang="en-US" dirty="0" err="1"/>
+              <a:t>everytime</a:t>
+            </a:r>
+            <a:r>
+              <a:rPr lang="en-US" dirty="0"/>
+              <a:t> values in the specified columns changes.</a:t>
+            </a:r>
+          </a:p>
+          <a:p>
+            <a:endParaRPr lang="en-US" dirty="0"/>
+          </a:p>
+          <a:p>
+            <a:r>
+              <a:rPr lang="en-US" dirty="0"/>
+              <a:t>If the clients table have the following columns:</a:t>
+            </a:r>
+          </a:p>
+          <a:p>
+            <a:r>
+              <a:rPr lang="en-US" dirty="0" err="1"/>
+              <a:t>clientID</a:t>
+            </a:r>
+            <a:r>
+              <a:rPr lang="en-US" dirty="0"/>
+              <a:t> | </a:t>
+            </a:r>
+            <a:r>
+              <a:rPr lang="en-US" dirty="0" err="1"/>
+              <a:t>clientName</a:t>
+            </a:r>
+            <a:r>
+              <a:rPr lang="en-US" dirty="0"/>
+              <a:t> | </a:t>
+            </a:r>
+            <a:r>
+              <a:rPr lang="en-US" dirty="0" err="1"/>
+              <a:t>clientCountry</a:t>
+            </a:r>
+            <a:endParaRPr lang="en-US" dirty="0"/>
+          </a:p>
+          <a:p>
+            <a:endParaRPr lang="en-US" dirty="0"/>
+          </a:p>
+          <a:p>
+            <a:r>
+              <a:rPr lang="en-US" dirty="0"/>
+              <a:t>The output snapshot will have the following columns:</a:t>
+            </a:r>
+          </a:p>
+          <a:p>
+            <a:endParaRPr lang="en-US" dirty="0"/>
+          </a:p>
+          <a:p>
+            <a:r>
+              <a:rPr lang="en-US" dirty="0" err="1"/>
+              <a:t>scd_id</a:t>
+            </a:r>
+            <a:r>
+              <a:rPr lang="en-US" dirty="0"/>
+              <a:t> | </a:t>
+            </a:r>
+            <a:r>
+              <a:rPr lang="en-US" dirty="0" err="1"/>
+              <a:t>clientID</a:t>
+            </a:r>
+            <a:r>
+              <a:rPr lang="en-US" dirty="0"/>
+              <a:t> | </a:t>
+            </a:r>
+            <a:r>
+              <a:rPr lang="en-US" dirty="0" err="1"/>
+              <a:t>clientName</a:t>
+            </a:r>
+            <a:r>
+              <a:rPr lang="en-US" dirty="0"/>
+              <a:t> | </a:t>
+            </a:r>
+            <a:r>
+              <a:rPr lang="en-US" dirty="0" err="1"/>
+              <a:t>clientCountry</a:t>
+            </a:r>
+            <a:r>
+              <a:rPr lang="en-US" dirty="0"/>
+              <a:t> | </a:t>
+            </a:r>
+            <a:r>
+              <a:rPr lang="en-US" dirty="0" err="1"/>
+              <a:t>valid_from</a:t>
+            </a:r>
+            <a:r>
+              <a:rPr lang="en-US" dirty="0"/>
+              <a:t> | </a:t>
+            </a:r>
+            <a:r>
+              <a:rPr lang="en-US" dirty="0" err="1"/>
+              <a:t>valid_to</a:t>
+            </a:r>
+            <a:endParaRPr lang="en-US" dirty="0"/>
+          </a:p>
+        </p:txBody>
+      </p:sp>
+      <p:pic>
+        <p:nvPicPr>
+          <p:cNvPr id="6" name="Picture 5">
+            <a:extLst>
+              <a:ext uri="{FF2B5EF4-FFF2-40B4-BE49-F238E27FC236}">
+                <a16:creationId xmlns:a16="http://schemas.microsoft.com/office/drawing/2014/main" id="{3AC5E69D-CE26-59A2-62CE-7A6AE9C4F85F}"/>
+              </a:ext>
+            </a:extLst>
+          </p:cNvPr>
+          <p:cNvPicPr>
+            <a:picLocks noChangeAspect="1"/>
+          </p:cNvPicPr>
+          <p:nvPr/>
+        </p:nvPicPr>
+        <p:blipFill>
+          <a:blip r:embed="rId2"/>
+          <a:stretch>
+            <a:fillRect/>
+          </a:stretch>
+        </p:blipFill>
+        <p:spPr>
+          <a:xfrm>
+            <a:off x="225283" y="4137187"/>
+            <a:ext cx="4147542" cy="2177187"/>
+          </a:xfrm>
+          <a:prstGeom prst="rect">
+            <a:avLst/>
+          </a:prstGeom>
+        </p:spPr>
+      </p:pic>
+    </p:spTree>
+    <p:extLst>
+      <p:ext uri="{BB962C8B-B14F-4D97-AF65-F5344CB8AC3E}">
+        <p14:creationId xmlns:p14="http://schemas.microsoft.com/office/powerpoint/2010/main" val="35436215"/>
+      </p:ext>
+    </p:extLst>
+  </p:cSld>
+  <p:clrMapOvr>
+    <a:masterClrMapping/>
+  </p:clrMapOvr>
+</p:sld>
+</file>
+
+<file path=ppt/slides/slide4.xml><?xml version="1.0" encoding="utf-8"?>
+<p:sld xmlns:a="http://schemas.openxmlformats.org/drawingml/2006/main" xmlns:r="http://schemas.openxmlformats.org/officeDocument/2006/relationships" xmlns:p="http://schemas.openxmlformats.org/presentationml/2006/main">
+  <p:cSld>
+    <p:spTree>
+      <p:nvGrpSpPr>
+        <p:cNvPr id="1" name="">
+          <a:extLst>
+            <a:ext uri="{FF2B5EF4-FFF2-40B4-BE49-F238E27FC236}">
               <a16:creationId xmlns:a16="http://schemas.microsoft.com/office/drawing/2014/main" id="{3527D707-25B0-F8CA-D74A-8B0B2B19A988}"/>
             </a:ext>
           </a:extLst>
@@ -4513,7 +5015,7 @@
 </p:sld>
 </file>
 
-<file path=ppt/slides/slide4.xml><?xml version="1.0" encoding="utf-8"?>
+<file path=ppt/slides/slide5.xml><?xml version="1.0" encoding="utf-8"?>
 <p:sld xmlns:a="http://schemas.openxmlformats.org/drawingml/2006/main" xmlns:r="http://schemas.openxmlformats.org/officeDocument/2006/relationships" xmlns:p="http://schemas.openxmlformats.org/presentationml/2006/main">
   <p:cSld>
     <p:spTree>
@@ -4654,7 +5156,160 @@
 </p:sld>
 </file>
 
-<file path=ppt/slides/slide5.xml><?xml version="1.0" encoding="utf-8"?>
+<file path=ppt/slides/slide6.xml><?xml version="1.0" encoding="utf-8"?>
+<p:sld xmlns:a="http://schemas.openxmlformats.org/drawingml/2006/main" xmlns:r="http://schemas.openxmlformats.org/officeDocument/2006/relationships" xmlns:p="http://schemas.openxmlformats.org/presentationml/2006/main">
+  <p:cSld>
+    <p:spTree>
+      <p:nvGrpSpPr>
+        <p:cNvPr id="1" name="">
+          <a:extLst>
+            <a:ext uri="{FF2B5EF4-FFF2-40B4-BE49-F238E27FC236}">
+              <a16:creationId xmlns:a16="http://schemas.microsoft.com/office/drawing/2014/main" id="{3CE7646A-8C09-C970-7177-42D906E528A8}"/>
+            </a:ext>
+          </a:extLst>
+        </p:cNvPr>
+        <p:cNvGrpSpPr/>
+        <p:nvPr/>
+      </p:nvGrpSpPr>
+      <p:grpSpPr>
+        <a:xfrm>
+          <a:off x="0" y="0"/>
+          <a:ext cx="0" cy="0"/>
+          <a:chOff x="0" y="0"/>
+          <a:chExt cx="0" cy="0"/>
+        </a:xfrm>
+      </p:grpSpPr>
+      <p:sp>
+        <p:nvSpPr>
+          <p:cNvPr id="4" name="TextBox 3">
+            <a:extLst>
+              <a:ext uri="{FF2B5EF4-FFF2-40B4-BE49-F238E27FC236}">
+                <a16:creationId xmlns:a16="http://schemas.microsoft.com/office/drawing/2014/main" id="{56162CC6-4A74-5249-51E6-69562DC5F668}"/>
+              </a:ext>
+            </a:extLst>
+          </p:cNvPr>
+          <p:cNvSpPr txBox="1"/>
+          <p:nvPr/>
+        </p:nvSpPr>
+        <p:spPr>
+          <a:xfrm>
+            <a:off x="0" y="0"/>
+            <a:ext cx="12192000" cy="477054"/>
+          </a:xfrm>
+          <a:prstGeom prst="rect">
+            <a:avLst/>
+          </a:prstGeom>
+          <a:noFill/>
+        </p:spPr>
+        <p:txBody>
+          <a:bodyPr wrap="square" rtlCol="0">
+            <a:spAutoFit/>
+          </a:bodyPr>
+          <a:lstStyle/>
+          <a:p>
+            <a:pPr algn="ctr"/>
+            <a:r>
+              <a:rPr lang="en-US" sz="2500" b="1" dirty="0"/>
+              <a:t>Data documentation</a:t>
+            </a:r>
+          </a:p>
+        </p:txBody>
+      </p:sp>
+      <p:sp>
+        <p:nvSpPr>
+          <p:cNvPr id="5" name="TextBox 4">
+            <a:extLst>
+              <a:ext uri="{FF2B5EF4-FFF2-40B4-BE49-F238E27FC236}">
+                <a16:creationId xmlns:a16="http://schemas.microsoft.com/office/drawing/2014/main" id="{8BE4B1AD-BDB0-0997-DC11-5A38199859C9}"/>
+              </a:ext>
+            </a:extLst>
+          </p:cNvPr>
+          <p:cNvSpPr txBox="1"/>
+          <p:nvPr/>
+        </p:nvSpPr>
+        <p:spPr>
+          <a:xfrm>
+            <a:off x="0" y="532309"/>
+            <a:ext cx="12192000" cy="923330"/>
+          </a:xfrm>
+          <a:prstGeom prst="rect">
+            <a:avLst/>
+          </a:prstGeom>
+          <a:noFill/>
+        </p:spPr>
+        <p:txBody>
+          <a:bodyPr wrap="square" rtlCol="0">
+            <a:spAutoFit/>
+          </a:bodyPr>
+          <a:lstStyle/>
+          <a:p>
+            <a:r>
+              <a:rPr lang="en-US" dirty="0"/>
+              <a:t>If we run </a:t>
+            </a:r>
+            <a:r>
+              <a:rPr lang="en-US" dirty="0" err="1"/>
+              <a:t>dbt</a:t>
+            </a:r>
+            <a:r>
+              <a:rPr lang="en-US" dirty="0"/>
+              <a:t> in Airflow using cosmos then we will also see data lineage in an Airflow graph. If we click on a specific task we can see the code used for building a table and logs. In that Airflow graph we can have also other tasks than </a:t>
+            </a:r>
+            <a:r>
+              <a:rPr lang="en-US" dirty="0" err="1"/>
+              <a:t>dbt</a:t>
+            </a:r>
+            <a:r>
+              <a:rPr lang="en-US" dirty="0"/>
+              <a:t> transformations.</a:t>
+            </a:r>
+          </a:p>
+        </p:txBody>
+      </p:sp>
+      <p:pic>
+        <p:nvPicPr>
+          <p:cNvPr id="8" name="Picture 7">
+            <a:extLst>
+              <a:ext uri="{FF2B5EF4-FFF2-40B4-BE49-F238E27FC236}">
+                <a16:creationId xmlns:a16="http://schemas.microsoft.com/office/drawing/2014/main" id="{17466192-5268-DDD7-45B9-EB330C1F0BE5}"/>
+              </a:ext>
+            </a:extLst>
+          </p:cNvPr>
+          <p:cNvPicPr>
+            <a:picLocks noChangeAspect="1"/>
+          </p:cNvPicPr>
+          <p:nvPr/>
+        </p:nvPicPr>
+        <p:blipFill>
+          <a:blip r:embed="rId2"/>
+          <a:stretch>
+            <a:fillRect/>
+          </a:stretch>
+        </p:blipFill>
+        <p:spPr>
+          <a:xfrm>
+            <a:off x="0" y="1680795"/>
+            <a:ext cx="12192000" cy="5177205"/>
+          </a:xfrm>
+          <a:prstGeom prst="rect">
+            <a:avLst/>
+          </a:prstGeom>
+        </p:spPr>
+      </p:pic>
+    </p:spTree>
+    <p:extLst>
+      <p:ext uri="{BB962C8B-B14F-4D97-AF65-F5344CB8AC3E}">
+        <p14:creationId xmlns:p14="http://schemas.microsoft.com/office/powerpoint/2010/main" val="3357874718"/>
+      </p:ext>
+    </p:extLst>
+  </p:cSld>
+  <p:clrMapOvr>
+    <a:masterClrMapping/>
+  </p:clrMapOvr>
+</p:sld>
+</file>
+
+<file path=ppt/slides/slide7.xml><?xml version="1.0" encoding="utf-8"?>
 <p:sld xmlns:a="http://schemas.openxmlformats.org/drawingml/2006/main" xmlns:r="http://schemas.openxmlformats.org/officeDocument/2006/relationships" xmlns:p="http://schemas.openxmlformats.org/presentationml/2006/main">
   <p:cSld>
     <p:spTree>
@@ -4708,7 +5363,7 @@
             <a:pPr algn="ctr"/>
             <a:r>
               <a:rPr lang="en-US" sz="2500" b="1" dirty="0"/>
-              <a:t>x</a:t>
+              <a:t>Specifying the target database</a:t>
             </a:r>
           </a:p>
         </p:txBody>
@@ -4728,7 +5383,7 @@
         <p:spPr>
           <a:xfrm>
             <a:off x="0" y="532309"/>
-            <a:ext cx="12192000" cy="369332"/>
+            <a:ext cx="12192000" cy="646331"/>
           </a:xfrm>
           <a:prstGeom prst="rect">
             <a:avLst/>
@@ -4743,15 +5398,772 @@
           <a:p>
             <a:r>
               <a:rPr lang="en-US" dirty="0"/>
-              <a:t>x</a:t>
-            </a:r>
-          </a:p>
-        </p:txBody>
-      </p:sp>
+              <a:t>In </a:t>
+            </a:r>
+            <a:r>
+              <a:rPr lang="en-US" dirty="0" err="1"/>
+              <a:t>dbt</a:t>
+            </a:r>
+            <a:r>
+              <a:rPr lang="en-US" dirty="0"/>
+              <a:t> we can easily define a location in a database our models will be built. We can specify different targets in the </a:t>
+            </a:r>
+            <a:r>
+              <a:rPr lang="en-US" dirty="0" err="1"/>
+              <a:t>profiles.yml</a:t>
+            </a:r>
+            <a:r>
+              <a:rPr lang="en-US" dirty="0"/>
+              <a:t> file.</a:t>
+            </a:r>
+          </a:p>
+        </p:txBody>
+      </p:sp>
+      <p:sp>
+        <p:nvSpPr>
+          <p:cNvPr id="6" name="TextBox 5">
+            <a:extLst>
+              <a:ext uri="{FF2B5EF4-FFF2-40B4-BE49-F238E27FC236}">
+                <a16:creationId xmlns:a16="http://schemas.microsoft.com/office/drawing/2014/main" id="{02FCB6BE-2B6F-3B29-2077-334F9D0498D9}"/>
+              </a:ext>
+            </a:extLst>
+          </p:cNvPr>
+          <p:cNvSpPr txBox="1"/>
+          <p:nvPr/>
+        </p:nvSpPr>
+        <p:spPr>
+          <a:xfrm>
+            <a:off x="0" y="1883121"/>
+            <a:ext cx="7288039" cy="646331"/>
+          </a:xfrm>
+          <a:prstGeom prst="rect">
+            <a:avLst/>
+          </a:prstGeom>
+          <a:noFill/>
+        </p:spPr>
+        <p:txBody>
+          <a:bodyPr wrap="square" rtlCol="0">
+            <a:spAutoFit/>
+          </a:bodyPr>
+          <a:lstStyle/>
+          <a:p>
+            <a:r>
+              <a:rPr lang="en-US" dirty="0"/>
+              <a:t>Here we have for example two targets, ‘dev’ and ‘prod’. For each of them we are specifying database parameters where they will be saving data.</a:t>
+            </a:r>
+          </a:p>
+        </p:txBody>
+      </p:sp>
+      <p:cxnSp>
+        <p:nvCxnSpPr>
+          <p:cNvPr id="11" name="Straight Arrow Connector 10">
+            <a:extLst>
+              <a:ext uri="{FF2B5EF4-FFF2-40B4-BE49-F238E27FC236}">
+                <a16:creationId xmlns:a16="http://schemas.microsoft.com/office/drawing/2014/main" id="{35BA746E-A111-8632-3289-5F68B8ACB1CA}"/>
+              </a:ext>
+            </a:extLst>
+          </p:cNvPr>
+          <p:cNvCxnSpPr>
+            <a:cxnSpLocks/>
+            <a:stCxn id="6" idx="3"/>
+          </p:cNvCxnSpPr>
+          <p:nvPr/>
+        </p:nvCxnSpPr>
+        <p:spPr>
+          <a:xfrm>
+            <a:off x="7288039" y="2206287"/>
+            <a:ext cx="525102" cy="0"/>
+          </a:xfrm>
+          <a:prstGeom prst="straightConnector1">
+            <a:avLst/>
+          </a:prstGeom>
+          <a:ln>
+            <a:tailEnd type="triangle"/>
+          </a:ln>
+        </p:spPr>
+        <p:style>
+          <a:lnRef idx="2">
+            <a:schemeClr val="accent1"/>
+          </a:lnRef>
+          <a:fillRef idx="0">
+            <a:schemeClr val="accent1"/>
+          </a:fillRef>
+          <a:effectRef idx="1">
+            <a:schemeClr val="accent1"/>
+          </a:effectRef>
+          <a:fontRef idx="minor">
+            <a:schemeClr val="tx1"/>
+          </a:fontRef>
+        </p:style>
+      </p:cxnSp>
+      <p:pic>
+        <p:nvPicPr>
+          <p:cNvPr id="13" name="Picture 12">
+            <a:extLst>
+              <a:ext uri="{FF2B5EF4-FFF2-40B4-BE49-F238E27FC236}">
+                <a16:creationId xmlns:a16="http://schemas.microsoft.com/office/drawing/2014/main" id="{5491D73E-0FB1-ABCE-258F-23A31A353B0D}"/>
+              </a:ext>
+            </a:extLst>
+          </p:cNvPr>
+          <p:cNvPicPr>
+            <a:picLocks noChangeAspect="1"/>
+          </p:cNvPicPr>
+          <p:nvPr/>
+        </p:nvPicPr>
+        <p:blipFill>
+          <a:blip r:embed="rId2"/>
+          <a:stretch>
+            <a:fillRect/>
+          </a:stretch>
+        </p:blipFill>
+        <p:spPr>
+          <a:xfrm>
+            <a:off x="7958394" y="1318653"/>
+            <a:ext cx="3753374" cy="5325218"/>
+          </a:xfrm>
+          <a:prstGeom prst="rect">
+            <a:avLst/>
+          </a:prstGeom>
+        </p:spPr>
+      </p:pic>
     </p:spTree>
     <p:extLst>
       <p:ext uri="{BB962C8B-B14F-4D97-AF65-F5344CB8AC3E}">
         <p14:creationId xmlns:p14="http://schemas.microsoft.com/office/powerpoint/2010/main" val="3981249663"/>
+      </p:ext>
+    </p:extLst>
+  </p:cSld>
+  <p:clrMapOvr>
+    <a:masterClrMapping/>
+  </p:clrMapOvr>
+</p:sld>
+</file>
+
+<file path=ppt/slides/slide8.xml><?xml version="1.0" encoding="utf-8"?>
+<p:sld xmlns:a="http://schemas.openxmlformats.org/drawingml/2006/main" xmlns:r="http://schemas.openxmlformats.org/officeDocument/2006/relationships" xmlns:p="http://schemas.openxmlformats.org/presentationml/2006/main">
+  <p:cSld>
+    <p:spTree>
+      <p:nvGrpSpPr>
+        <p:cNvPr id="1" name="">
+          <a:extLst>
+            <a:ext uri="{FF2B5EF4-FFF2-40B4-BE49-F238E27FC236}">
+              <a16:creationId xmlns:a16="http://schemas.microsoft.com/office/drawing/2014/main" id="{A49EB96B-DBC0-0872-2625-C933B972097F}"/>
+            </a:ext>
+          </a:extLst>
+        </p:cNvPr>
+        <p:cNvGrpSpPr/>
+        <p:nvPr/>
+      </p:nvGrpSpPr>
+      <p:grpSpPr>
+        <a:xfrm>
+          <a:off x="0" y="0"/>
+          <a:ext cx="0" cy="0"/>
+          <a:chOff x="0" y="0"/>
+          <a:chExt cx="0" cy="0"/>
+        </a:xfrm>
+      </p:grpSpPr>
+      <p:sp>
+        <p:nvSpPr>
+          <p:cNvPr id="4" name="TextBox 3">
+            <a:extLst>
+              <a:ext uri="{FF2B5EF4-FFF2-40B4-BE49-F238E27FC236}">
+                <a16:creationId xmlns:a16="http://schemas.microsoft.com/office/drawing/2014/main" id="{742650C3-909D-5D80-F0A7-8E759BA42683}"/>
+              </a:ext>
+            </a:extLst>
+          </p:cNvPr>
+          <p:cNvSpPr txBox="1"/>
+          <p:nvPr/>
+        </p:nvSpPr>
+        <p:spPr>
+          <a:xfrm>
+            <a:off x="0" y="0"/>
+            <a:ext cx="12192000" cy="477054"/>
+          </a:xfrm>
+          <a:prstGeom prst="rect">
+            <a:avLst/>
+          </a:prstGeom>
+          <a:noFill/>
+        </p:spPr>
+        <p:txBody>
+          <a:bodyPr wrap="square" rtlCol="0">
+            <a:spAutoFit/>
+          </a:bodyPr>
+          <a:lstStyle/>
+          <a:p>
+            <a:pPr algn="ctr"/>
+            <a:r>
+              <a:rPr lang="en-US" sz="2500" b="1" dirty="0"/>
+              <a:t>Specifying the target database</a:t>
+            </a:r>
+          </a:p>
+        </p:txBody>
+      </p:sp>
+      <p:sp>
+        <p:nvSpPr>
+          <p:cNvPr id="9" name="TextBox 8">
+            <a:extLst>
+              <a:ext uri="{FF2B5EF4-FFF2-40B4-BE49-F238E27FC236}">
+                <a16:creationId xmlns:a16="http://schemas.microsoft.com/office/drawing/2014/main" id="{6F9B3B85-3D7A-971D-8929-DE8AA4A08990}"/>
+              </a:ext>
+            </a:extLst>
+          </p:cNvPr>
+          <p:cNvSpPr txBox="1"/>
+          <p:nvPr/>
+        </p:nvSpPr>
+        <p:spPr>
+          <a:xfrm>
+            <a:off x="81481" y="1060185"/>
+            <a:ext cx="4888871" cy="646331"/>
+          </a:xfrm>
+          <a:prstGeom prst="rect">
+            <a:avLst/>
+          </a:prstGeom>
+          <a:noFill/>
+        </p:spPr>
+        <p:txBody>
+          <a:bodyPr wrap="square" rtlCol="0">
+            <a:spAutoFit/>
+          </a:bodyPr>
+          <a:lstStyle/>
+          <a:p>
+            <a:r>
+              <a:rPr lang="en-US" dirty="0"/>
+              <a:t>Then in a Python script creating Airflow DAG we can specify which target we want to use:</a:t>
+            </a:r>
+          </a:p>
+        </p:txBody>
+      </p:sp>
+      <p:pic>
+        <p:nvPicPr>
+          <p:cNvPr id="3" name="Picture 2">
+            <a:extLst>
+              <a:ext uri="{FF2B5EF4-FFF2-40B4-BE49-F238E27FC236}">
+                <a16:creationId xmlns:a16="http://schemas.microsoft.com/office/drawing/2014/main" id="{FD94EF27-299E-1A37-079D-380BFDDA8C36}"/>
+              </a:ext>
+            </a:extLst>
+          </p:cNvPr>
+          <p:cNvPicPr>
+            <a:picLocks noChangeAspect="1"/>
+          </p:cNvPicPr>
+          <p:nvPr/>
+        </p:nvPicPr>
+        <p:blipFill>
+          <a:blip r:embed="rId2"/>
+          <a:stretch>
+            <a:fillRect/>
+          </a:stretch>
+        </p:blipFill>
+        <p:spPr>
+          <a:xfrm>
+            <a:off x="6476245" y="909176"/>
+            <a:ext cx="4553585" cy="5668166"/>
+          </a:xfrm>
+          <a:prstGeom prst="rect">
+            <a:avLst/>
+          </a:prstGeom>
+        </p:spPr>
+      </p:pic>
+      <p:sp>
+        <p:nvSpPr>
+          <p:cNvPr id="7" name="Rectangle 6">
+            <a:extLst>
+              <a:ext uri="{FF2B5EF4-FFF2-40B4-BE49-F238E27FC236}">
+                <a16:creationId xmlns:a16="http://schemas.microsoft.com/office/drawing/2014/main" id="{17DE979D-40C3-0768-D0D8-21FE20105BE2}"/>
+              </a:ext>
+            </a:extLst>
+          </p:cNvPr>
+          <p:cNvSpPr/>
+          <p:nvPr/>
+        </p:nvSpPr>
+        <p:spPr>
+          <a:xfrm>
+            <a:off x="6355533" y="1269401"/>
+            <a:ext cx="4771176" cy="213540"/>
+          </a:xfrm>
+          <a:prstGeom prst="rect">
+            <a:avLst/>
+          </a:prstGeom>
+          <a:noFill/>
+          <a:ln>
+            <a:solidFill>
+              <a:srgbClr val="FF0000"/>
+            </a:solidFill>
+          </a:ln>
+        </p:spPr>
+        <p:style>
+          <a:lnRef idx="2">
+            <a:schemeClr val="accent1">
+              <a:shade val="15000"/>
+            </a:schemeClr>
+          </a:lnRef>
+          <a:fillRef idx="1">
+            <a:schemeClr val="accent1"/>
+          </a:fillRef>
+          <a:effectRef idx="0">
+            <a:schemeClr val="accent1"/>
+          </a:effectRef>
+          <a:fontRef idx="minor">
+            <a:schemeClr val="lt1"/>
+          </a:fontRef>
+        </p:style>
+        <p:txBody>
+          <a:bodyPr rtlCol="0" anchor="ctr"/>
+          <a:lstStyle/>
+          <a:p>
+            <a:pPr algn="ctr"/>
+            <a:endParaRPr lang="en-US"/>
+          </a:p>
+        </p:txBody>
+      </p:sp>
+      <p:cxnSp>
+        <p:nvCxnSpPr>
+          <p:cNvPr id="12" name="Straight Arrow Connector 11">
+            <a:extLst>
+              <a:ext uri="{FF2B5EF4-FFF2-40B4-BE49-F238E27FC236}">
+                <a16:creationId xmlns:a16="http://schemas.microsoft.com/office/drawing/2014/main" id="{023CB2FD-DFF4-5CCA-CF67-A9E03C6899EF}"/>
+              </a:ext>
+            </a:extLst>
+          </p:cNvPr>
+          <p:cNvCxnSpPr>
+            <a:stCxn id="9" idx="3"/>
+          </p:cNvCxnSpPr>
+          <p:nvPr/>
+        </p:nvCxnSpPr>
+        <p:spPr>
+          <a:xfrm>
+            <a:off x="4970352" y="1383351"/>
+            <a:ext cx="1125648" cy="1829"/>
+          </a:xfrm>
+          <a:prstGeom prst="straightConnector1">
+            <a:avLst/>
+          </a:prstGeom>
+          <a:ln>
+            <a:tailEnd type="triangle"/>
+          </a:ln>
+        </p:spPr>
+        <p:style>
+          <a:lnRef idx="2">
+            <a:schemeClr val="accent1"/>
+          </a:lnRef>
+          <a:fillRef idx="0">
+            <a:schemeClr val="accent1"/>
+          </a:fillRef>
+          <a:effectRef idx="1">
+            <a:schemeClr val="accent1"/>
+          </a:effectRef>
+          <a:fontRef idx="minor">
+            <a:schemeClr val="tx1"/>
+          </a:fontRef>
+        </p:style>
+      </p:cxnSp>
+      <p:sp>
+        <p:nvSpPr>
+          <p:cNvPr id="14" name="TextBox 13">
+            <a:extLst>
+              <a:ext uri="{FF2B5EF4-FFF2-40B4-BE49-F238E27FC236}">
+                <a16:creationId xmlns:a16="http://schemas.microsoft.com/office/drawing/2014/main" id="{FAAFFF08-48A5-DF8D-A7CF-1963A744F989}"/>
+              </a:ext>
+            </a:extLst>
+          </p:cNvPr>
+          <p:cNvSpPr txBox="1"/>
+          <p:nvPr/>
+        </p:nvSpPr>
+        <p:spPr>
+          <a:xfrm>
+            <a:off x="47975" y="4508626"/>
+            <a:ext cx="4888871" cy="369332"/>
+          </a:xfrm>
+          <a:prstGeom prst="rect">
+            <a:avLst/>
+          </a:prstGeom>
+          <a:noFill/>
+        </p:spPr>
+        <p:txBody>
+          <a:bodyPr wrap="square" rtlCol="0">
+            <a:spAutoFit/>
+          </a:bodyPr>
+          <a:lstStyle/>
+          <a:p>
+            <a:r>
+              <a:rPr lang="en-US" dirty="0"/>
+              <a:t>And which tables we want to build in that target:</a:t>
+            </a:r>
+          </a:p>
+        </p:txBody>
+      </p:sp>
+      <p:cxnSp>
+        <p:nvCxnSpPr>
+          <p:cNvPr id="15" name="Straight Arrow Connector 14">
+            <a:extLst>
+              <a:ext uri="{FF2B5EF4-FFF2-40B4-BE49-F238E27FC236}">
+                <a16:creationId xmlns:a16="http://schemas.microsoft.com/office/drawing/2014/main" id="{D74041D8-644B-138F-1607-E58817BA4DC7}"/>
+              </a:ext>
+            </a:extLst>
+          </p:cNvPr>
+          <p:cNvCxnSpPr/>
+          <p:nvPr/>
+        </p:nvCxnSpPr>
+        <p:spPr>
+          <a:xfrm>
+            <a:off x="5097856" y="4693292"/>
+            <a:ext cx="1125648" cy="1829"/>
+          </a:xfrm>
+          <a:prstGeom prst="straightConnector1">
+            <a:avLst/>
+          </a:prstGeom>
+          <a:ln>
+            <a:tailEnd type="triangle"/>
+          </a:ln>
+        </p:spPr>
+        <p:style>
+          <a:lnRef idx="2">
+            <a:schemeClr val="accent1"/>
+          </a:lnRef>
+          <a:fillRef idx="0">
+            <a:schemeClr val="accent1"/>
+          </a:fillRef>
+          <a:effectRef idx="1">
+            <a:schemeClr val="accent1"/>
+          </a:effectRef>
+          <a:fontRef idx="minor">
+            <a:schemeClr val="tx1"/>
+          </a:fontRef>
+        </p:style>
+      </p:cxnSp>
+      <p:sp>
+        <p:nvSpPr>
+          <p:cNvPr id="16" name="Rectangle 15">
+            <a:extLst>
+              <a:ext uri="{FF2B5EF4-FFF2-40B4-BE49-F238E27FC236}">
+                <a16:creationId xmlns:a16="http://schemas.microsoft.com/office/drawing/2014/main" id="{DBC6D68A-847F-E592-7A40-0A6AB2CEF5A6}"/>
+              </a:ext>
+            </a:extLst>
+          </p:cNvPr>
+          <p:cNvSpPr/>
+          <p:nvPr/>
+        </p:nvSpPr>
+        <p:spPr>
+          <a:xfrm>
+            <a:off x="6355533" y="4508626"/>
+            <a:ext cx="4835307" cy="477054"/>
+          </a:xfrm>
+          <a:prstGeom prst="rect">
+            <a:avLst/>
+          </a:prstGeom>
+          <a:noFill/>
+          <a:ln>
+            <a:solidFill>
+              <a:srgbClr val="FF0000"/>
+            </a:solidFill>
+          </a:ln>
+        </p:spPr>
+        <p:style>
+          <a:lnRef idx="2">
+            <a:schemeClr val="accent1">
+              <a:shade val="15000"/>
+            </a:schemeClr>
+          </a:lnRef>
+          <a:fillRef idx="1">
+            <a:schemeClr val="accent1"/>
+          </a:fillRef>
+          <a:effectRef idx="0">
+            <a:schemeClr val="accent1"/>
+          </a:effectRef>
+          <a:fontRef idx="minor">
+            <a:schemeClr val="lt1"/>
+          </a:fontRef>
+        </p:style>
+        <p:txBody>
+          <a:bodyPr rtlCol="0" anchor="ctr"/>
+          <a:lstStyle/>
+          <a:p>
+            <a:pPr algn="ctr"/>
+            <a:endParaRPr lang="en-US"/>
+          </a:p>
+        </p:txBody>
+      </p:sp>
+    </p:spTree>
+    <p:extLst>
+      <p:ext uri="{BB962C8B-B14F-4D97-AF65-F5344CB8AC3E}">
+        <p14:creationId xmlns:p14="http://schemas.microsoft.com/office/powerpoint/2010/main" val="3390956857"/>
+      </p:ext>
+    </p:extLst>
+  </p:cSld>
+  <p:clrMapOvr>
+    <a:masterClrMapping/>
+  </p:clrMapOvr>
+</p:sld>
+</file>
+
+<file path=ppt/slides/slide9.xml><?xml version="1.0" encoding="utf-8"?>
+<p:sld xmlns:a="http://schemas.openxmlformats.org/drawingml/2006/main" xmlns:r="http://schemas.openxmlformats.org/officeDocument/2006/relationships" xmlns:p="http://schemas.openxmlformats.org/presentationml/2006/main">
+  <p:cSld>
+    <p:spTree>
+      <p:nvGrpSpPr>
+        <p:cNvPr id="1" name="">
+          <a:extLst>
+            <a:ext uri="{FF2B5EF4-FFF2-40B4-BE49-F238E27FC236}">
+              <a16:creationId xmlns:a16="http://schemas.microsoft.com/office/drawing/2014/main" id="{EB899668-8CD2-3BAD-BBB2-E66D7E0169F3}"/>
+            </a:ext>
+          </a:extLst>
+        </p:cNvPr>
+        <p:cNvGrpSpPr/>
+        <p:nvPr/>
+      </p:nvGrpSpPr>
+      <p:grpSpPr>
+        <a:xfrm>
+          <a:off x="0" y="0"/>
+          <a:ext cx="0" cy="0"/>
+          <a:chOff x="0" y="0"/>
+          <a:chExt cx="0" cy="0"/>
+        </a:xfrm>
+      </p:grpSpPr>
+      <p:sp>
+        <p:nvSpPr>
+          <p:cNvPr id="4" name="TextBox 3">
+            <a:extLst>
+              <a:ext uri="{FF2B5EF4-FFF2-40B4-BE49-F238E27FC236}">
+                <a16:creationId xmlns:a16="http://schemas.microsoft.com/office/drawing/2014/main" id="{99D360EA-86B2-AB2E-0579-2F39A9213C39}"/>
+              </a:ext>
+            </a:extLst>
+          </p:cNvPr>
+          <p:cNvSpPr txBox="1"/>
+          <p:nvPr/>
+        </p:nvSpPr>
+        <p:spPr>
+          <a:xfrm>
+            <a:off x="0" y="0"/>
+            <a:ext cx="12192000" cy="523220"/>
+          </a:xfrm>
+          <a:prstGeom prst="rect">
+            <a:avLst/>
+          </a:prstGeom>
+          <a:noFill/>
+        </p:spPr>
+        <p:txBody>
+          <a:bodyPr wrap="square" rtlCol="0">
+            <a:spAutoFit/>
+          </a:bodyPr>
+          <a:lstStyle/>
+          <a:p>
+            <a:pPr algn="ctr"/>
+            <a:r>
+              <a:rPr lang="en-US" sz="2800" b="1" dirty="0" err="1"/>
+              <a:t>dbt_project.yml</a:t>
+            </a:r>
+            <a:endParaRPr lang="en-US" sz="2500" b="1" dirty="0"/>
+          </a:p>
+        </p:txBody>
+      </p:sp>
+      <p:sp>
+        <p:nvSpPr>
+          <p:cNvPr id="5" name="TextBox 4">
+            <a:extLst>
+              <a:ext uri="{FF2B5EF4-FFF2-40B4-BE49-F238E27FC236}">
+                <a16:creationId xmlns:a16="http://schemas.microsoft.com/office/drawing/2014/main" id="{A5FF3DD5-B910-9D3E-4D85-8CA9F819E51C}"/>
+              </a:ext>
+            </a:extLst>
+          </p:cNvPr>
+          <p:cNvSpPr txBox="1"/>
+          <p:nvPr/>
+        </p:nvSpPr>
+        <p:spPr>
+          <a:xfrm>
+            <a:off x="0" y="543626"/>
+            <a:ext cx="12192000" cy="1477328"/>
+          </a:xfrm>
+          <a:prstGeom prst="rect">
+            <a:avLst/>
+          </a:prstGeom>
+          <a:noFill/>
+        </p:spPr>
+        <p:txBody>
+          <a:bodyPr wrap="square" rtlCol="0">
+            <a:spAutoFit/>
+          </a:bodyPr>
+          <a:lstStyle/>
+          <a:p>
+            <a:r>
+              <a:rPr lang="en-US" dirty="0"/>
+              <a:t>In the </a:t>
+            </a:r>
+            <a:r>
+              <a:rPr lang="en-US" dirty="0" err="1"/>
+              <a:t>dbt_project.yml</a:t>
+            </a:r>
+            <a:r>
+              <a:rPr lang="en-US" dirty="0"/>
+              <a:t> file we are specifying our </a:t>
+            </a:r>
+            <a:r>
+              <a:rPr lang="en-US" dirty="0" err="1"/>
+              <a:t>dbt</a:t>
+            </a:r>
+            <a:r>
+              <a:rPr lang="en-US" dirty="0"/>
+              <a:t> project configuration. </a:t>
+            </a:r>
+          </a:p>
+          <a:p>
+            <a:endParaRPr lang="en-US" dirty="0"/>
+          </a:p>
+          <a:p>
+            <a:r>
+              <a:rPr lang="en-US" dirty="0"/>
+              <a:t>For example we might create models in different folders and in the </a:t>
+            </a:r>
+            <a:r>
+              <a:rPr lang="en-US" dirty="0" err="1"/>
+              <a:t>dbt_project.yml</a:t>
+            </a:r>
+            <a:r>
+              <a:rPr lang="en-US" dirty="0"/>
+              <a:t> we are specifying where those models will be saved in the database (in which database and schema) and how they will be materialized (we can create a view or a table).</a:t>
+            </a:r>
+          </a:p>
+        </p:txBody>
+      </p:sp>
+      <p:pic>
+        <p:nvPicPr>
+          <p:cNvPr id="6" name="Picture 5">
+            <a:extLst>
+              <a:ext uri="{FF2B5EF4-FFF2-40B4-BE49-F238E27FC236}">
+                <a16:creationId xmlns:a16="http://schemas.microsoft.com/office/drawing/2014/main" id="{44494547-7C8A-FB0A-7CA4-987BECA425BE}"/>
+              </a:ext>
+            </a:extLst>
+          </p:cNvPr>
+          <p:cNvPicPr>
+            <a:picLocks noChangeAspect="1"/>
+          </p:cNvPicPr>
+          <p:nvPr/>
+        </p:nvPicPr>
+        <p:blipFill>
+          <a:blip r:embed="rId2"/>
+          <a:stretch>
+            <a:fillRect/>
+          </a:stretch>
+        </p:blipFill>
+        <p:spPr>
+          <a:xfrm>
+            <a:off x="649270" y="3103490"/>
+            <a:ext cx="1638529" cy="2114845"/>
+          </a:xfrm>
+          <a:prstGeom prst="rect">
+            <a:avLst/>
+          </a:prstGeom>
+        </p:spPr>
+      </p:pic>
+      <p:pic>
+        <p:nvPicPr>
+          <p:cNvPr id="8" name="Picture 7">
+            <a:extLst>
+              <a:ext uri="{FF2B5EF4-FFF2-40B4-BE49-F238E27FC236}">
+                <a16:creationId xmlns:a16="http://schemas.microsoft.com/office/drawing/2014/main" id="{970A0D6A-21AD-7BC6-8304-892EAE9E8F54}"/>
+              </a:ext>
+            </a:extLst>
+          </p:cNvPr>
+          <p:cNvPicPr>
+            <a:picLocks noChangeAspect="1"/>
+          </p:cNvPicPr>
+          <p:nvPr/>
+        </p:nvPicPr>
+        <p:blipFill>
+          <a:blip r:embed="rId3"/>
+          <a:stretch>
+            <a:fillRect/>
+          </a:stretch>
+        </p:blipFill>
+        <p:spPr>
+          <a:xfrm>
+            <a:off x="3885221" y="3160648"/>
+            <a:ext cx="5906324" cy="2057687"/>
+          </a:xfrm>
+          <a:prstGeom prst="rect">
+            <a:avLst/>
+          </a:prstGeom>
+        </p:spPr>
+      </p:pic>
+      <p:sp>
+        <p:nvSpPr>
+          <p:cNvPr id="9" name="TextBox 8">
+            <a:extLst>
+              <a:ext uri="{FF2B5EF4-FFF2-40B4-BE49-F238E27FC236}">
+                <a16:creationId xmlns:a16="http://schemas.microsoft.com/office/drawing/2014/main" id="{7326E37E-A87E-18D6-703E-6A742C7EADB5}"/>
+              </a:ext>
+            </a:extLst>
+          </p:cNvPr>
+          <p:cNvSpPr txBox="1"/>
+          <p:nvPr/>
+        </p:nvSpPr>
+        <p:spPr>
+          <a:xfrm>
+            <a:off x="318744" y="2307756"/>
+            <a:ext cx="2299580" cy="646331"/>
+          </a:xfrm>
+          <a:prstGeom prst="rect">
+            <a:avLst/>
+          </a:prstGeom>
+          <a:noFill/>
+        </p:spPr>
+        <p:txBody>
+          <a:bodyPr wrap="square" rtlCol="0">
+            <a:spAutoFit/>
+          </a:bodyPr>
+          <a:lstStyle/>
+          <a:p>
+            <a:pPr algn="ctr"/>
+            <a:r>
+              <a:rPr lang="en-US" dirty="0" err="1"/>
+              <a:t>dbt</a:t>
+            </a:r>
+            <a:r>
+              <a:rPr lang="en-US" dirty="0"/>
+              <a:t> models structure in a project</a:t>
+            </a:r>
+          </a:p>
+        </p:txBody>
+      </p:sp>
+      <p:sp>
+        <p:nvSpPr>
+          <p:cNvPr id="13" name="TextBox 12">
+            <a:extLst>
+              <a:ext uri="{FF2B5EF4-FFF2-40B4-BE49-F238E27FC236}">
+                <a16:creationId xmlns:a16="http://schemas.microsoft.com/office/drawing/2014/main" id="{1B304FBA-9C29-EE96-87B2-692B53F654FD}"/>
+              </a:ext>
+            </a:extLst>
+          </p:cNvPr>
+          <p:cNvSpPr txBox="1"/>
+          <p:nvPr/>
+        </p:nvSpPr>
+        <p:spPr>
+          <a:xfrm>
+            <a:off x="5756496" y="2584755"/>
+            <a:ext cx="2299580" cy="369332"/>
+          </a:xfrm>
+          <a:prstGeom prst="rect">
+            <a:avLst/>
+          </a:prstGeom>
+          <a:noFill/>
+        </p:spPr>
+        <p:txBody>
+          <a:bodyPr wrap="square" rtlCol="0">
+            <a:spAutoFit/>
+          </a:bodyPr>
+          <a:lstStyle/>
+          <a:p>
+            <a:pPr algn="ctr"/>
+            <a:r>
+              <a:rPr lang="en-US" dirty="0" err="1"/>
+              <a:t>dbt_project.yml</a:t>
+            </a:r>
+            <a:endParaRPr lang="en-US" dirty="0"/>
+          </a:p>
+        </p:txBody>
+      </p:sp>
+    </p:spTree>
+    <p:extLst>
+      <p:ext uri="{BB962C8B-B14F-4D97-AF65-F5344CB8AC3E}">
+        <p14:creationId xmlns:p14="http://schemas.microsoft.com/office/powerpoint/2010/main" val="3527769515"/>
       </p:ext>
     </p:extLst>
   </p:cSld>

</xml_diff>